<commit_message>
attempt to fix website
</commit_message>
<xml_diff>
--- a/Documentation/Weekly Report/week14/CMSC-4920-Week14Report-Group2.pptx
+++ b/Documentation/Weekly Report/week14/CMSC-4920-Week14Report-Group2.pptx
@@ -5,16 +5,17 @@
     <p:sldMasterId id="2147483648" r:id="rId1"/>
   </p:sldMasterIdLst>
   <p:notesMasterIdLst>
-    <p:notesMasterId r:id="rId9"/>
+    <p:notesMasterId r:id="rId10"/>
   </p:notesMasterIdLst>
   <p:sldIdLst>
     <p:sldId id="256" r:id="rId2"/>
     <p:sldId id="257" r:id="rId3"/>
     <p:sldId id="265" r:id="rId4"/>
     <p:sldId id="266" r:id="rId5"/>
-    <p:sldId id="258" r:id="rId6"/>
-    <p:sldId id="259" r:id="rId7"/>
-    <p:sldId id="260" r:id="rId8"/>
+    <p:sldId id="267" r:id="rId6"/>
+    <p:sldId id="258" r:id="rId7"/>
+    <p:sldId id="259" r:id="rId8"/>
+    <p:sldId id="260" r:id="rId9"/>
   </p:sldIdLst>
   <p:sldSz cx="12192000" cy="6858000"/>
   <p:notesSz cx="6858000" cy="9144000"/>
@@ -124,7 +125,7 @@
 <file path=ppt/revisionInfo.xml><?xml version="1.0" encoding="utf-8"?>
 <p1510:revInfo xmlns:a="http://schemas.openxmlformats.org/drawingml/2006/main" xmlns:r="http://schemas.openxmlformats.org/officeDocument/2006/relationships" xmlns:p1510="http://schemas.microsoft.com/office/powerpoint/2015/10/main">
   <p1510:revLst>
-    <p1510:client id="{CCB6696A-4F6B-4729-BD3B-FECB1658CA32}" v="2" dt="2026-04-16T20:33:55.802"/>
+    <p1510:client id="{CCB6696A-4F6B-4729-BD3B-FECB1658CA32}" v="16" dt="2026-04-19T16:46:20.451"/>
   </p1510:revLst>
 </p1510:revInfo>
 </file>
@@ -181,31 +182,71 @@
   <pc:docChgLst>
     <pc:chgData name="Margo Bonal" userId="18c9fa0f-b53d-478b-9dc0-6ad88786c19f" providerId="ADAL" clId="{93D479E5-F67F-4B8A-A78F-A0B574A116B6}"/>
     <pc:docChg chg="undo redo custSel addSld delSld modSld">
-      <pc:chgData name="Margo Bonal" userId="18c9fa0f-b53d-478b-9dc0-6ad88786c19f" providerId="ADAL" clId="{93D479E5-F67F-4B8A-A78F-A0B574A116B6}" dt="2026-04-16T20:37:33.721" v="1798" actId="20577"/>
+      <pc:chgData name="Margo Bonal" userId="18c9fa0f-b53d-478b-9dc0-6ad88786c19f" providerId="ADAL" clId="{93D479E5-F67F-4B8A-A78F-A0B574A116B6}" dt="2026-04-19T16:46:20.913" v="1836" actId="20577"/>
       <pc:docMkLst>
         <pc:docMk/>
       </pc:docMkLst>
-      <pc:sldChg chg="addSp delSp modSp mod">
-        <pc:chgData name="Margo Bonal" userId="18c9fa0f-b53d-478b-9dc0-6ad88786c19f" providerId="ADAL" clId="{93D479E5-F67F-4B8A-A78F-A0B574A116B6}" dt="2026-04-12T10:51:28.860" v="1342" actId="14100"/>
+      <pc:sldChg chg="addSp delSp modSp add del mod">
+        <pc:chgData name="Margo Bonal" userId="18c9fa0f-b53d-478b-9dc0-6ad88786c19f" providerId="ADAL" clId="{93D479E5-F67F-4B8A-A78F-A0B574A116B6}" dt="2026-04-19T16:45:13.626" v="1822" actId="14100"/>
         <pc:sldMkLst>
           <pc:docMk/>
           <pc:sldMk cId="3713997872" sldId="259"/>
         </pc:sldMkLst>
-        <pc:picChg chg="add mod">
-          <ac:chgData name="Margo Bonal" userId="18c9fa0f-b53d-478b-9dc0-6ad88786c19f" providerId="ADAL" clId="{93D479E5-F67F-4B8A-A78F-A0B574A116B6}" dt="2026-04-12T10:51:28.860" v="1342" actId="14100"/>
+        <pc:picChg chg="add del mod">
+          <ac:chgData name="Margo Bonal" userId="18c9fa0f-b53d-478b-9dc0-6ad88786c19f" providerId="ADAL" clId="{93D479E5-F67F-4B8A-A78F-A0B574A116B6}" dt="2026-04-19T16:44:51.534" v="1816" actId="478"/>
           <ac:picMkLst>
             <pc:docMk/>
             <pc:sldMk cId="3713997872" sldId="259"/>
             <ac:picMk id="5" creationId="{B0894097-9C9B-8B23-3BC5-11C154EBBAD5}"/>
           </ac:picMkLst>
         </pc:picChg>
+        <pc:picChg chg="add mod">
+          <ac:chgData name="Margo Bonal" userId="18c9fa0f-b53d-478b-9dc0-6ad88786c19f" providerId="ADAL" clId="{93D479E5-F67F-4B8A-A78F-A0B574A116B6}" dt="2026-04-19T16:45:13.626" v="1822" actId="14100"/>
+          <ac:picMkLst>
+            <pc:docMk/>
+            <pc:sldMk cId="3713997872" sldId="259"/>
+            <ac:picMk id="6" creationId="{39CFE319-1228-241C-E27B-2F090068170E}"/>
+          </ac:picMkLst>
+        </pc:picChg>
       </pc:sldChg>
-      <pc:sldChg chg="modSp del mod">
-        <pc:chgData name="Margo Bonal" userId="18c9fa0f-b53d-478b-9dc0-6ad88786c19f" providerId="ADAL" clId="{93D479E5-F67F-4B8A-A78F-A0B574A116B6}" dt="2026-04-16T20:30:48.780" v="1491" actId="2696"/>
+      <pc:sldChg chg="addSp delSp modSp mod">
+        <pc:chgData name="Margo Bonal" userId="18c9fa0f-b53d-478b-9dc0-6ad88786c19f" providerId="ADAL" clId="{93D479E5-F67F-4B8A-A78F-A0B574A116B6}" dt="2026-04-19T16:46:20.913" v="1836" actId="20577"/>
         <pc:sldMkLst>
           <pc:docMk/>
-          <pc:sldMk cId="2561402868" sldId="264"/>
+          <pc:sldMk cId="3921983173" sldId="260"/>
         </pc:sldMkLst>
+        <pc:spChg chg="del">
+          <ac:chgData name="Margo Bonal" userId="18c9fa0f-b53d-478b-9dc0-6ad88786c19f" providerId="ADAL" clId="{93D479E5-F67F-4B8A-A78F-A0B574A116B6}" dt="2026-04-19T16:45:57.441" v="1829" actId="478"/>
+          <ac:spMkLst>
+            <pc:docMk/>
+            <pc:sldMk cId="3921983173" sldId="260"/>
+            <ac:spMk id="2" creationId="{9C9AD6B9-1CEE-7976-0BB7-22F5E9535735}"/>
+          </ac:spMkLst>
+        </pc:spChg>
+        <pc:spChg chg="add mod">
+          <ac:chgData name="Margo Bonal" userId="18c9fa0f-b53d-478b-9dc0-6ad88786c19f" providerId="ADAL" clId="{93D479E5-F67F-4B8A-A78F-A0B574A116B6}" dt="2026-04-19T16:45:38.715" v="1828"/>
+          <ac:spMkLst>
+            <pc:docMk/>
+            <pc:sldMk cId="3921983173" sldId="260"/>
+            <ac:spMk id="3" creationId="{267F5CC8-9B6E-F99B-0D5E-470962CD289B}"/>
+          </ac:spMkLst>
+        </pc:spChg>
+        <pc:spChg chg="add del mod">
+          <ac:chgData name="Margo Bonal" userId="18c9fa0f-b53d-478b-9dc0-6ad88786c19f" providerId="ADAL" clId="{93D479E5-F67F-4B8A-A78F-A0B574A116B6}" dt="2026-04-19T16:45:59.757" v="1830"/>
+          <ac:spMkLst>
+            <pc:docMk/>
+            <pc:sldMk cId="3921983173" sldId="260"/>
+            <ac:spMk id="5" creationId="{2923A220-7682-DF2A-2735-6ADA53EF7455}"/>
+          </ac:spMkLst>
+        </pc:spChg>
+        <pc:spChg chg="add mod">
+          <ac:chgData name="Margo Bonal" userId="18c9fa0f-b53d-478b-9dc0-6ad88786c19f" providerId="ADAL" clId="{93D479E5-F67F-4B8A-A78F-A0B574A116B6}" dt="2026-04-19T16:46:20.913" v="1836" actId="20577"/>
+          <ac:spMkLst>
+            <pc:docMk/>
+            <pc:sldMk cId="3921983173" sldId="260"/>
+            <ac:spMk id="6" creationId="{41FAB8FA-2602-2A18-903D-B03E3D5EF300}"/>
+          </ac:spMkLst>
+        </pc:spChg>
       </pc:sldChg>
       <pc:sldChg chg="delSp modSp mod">
         <pc:chgData name="Margo Bonal" userId="18c9fa0f-b53d-478b-9dc0-6ad88786c19f" providerId="ADAL" clId="{93D479E5-F67F-4B8A-A78F-A0B574A116B6}" dt="2026-04-16T20:37:33.721" v="1798" actId="20577"/>
@@ -223,7 +264,7 @@
         </pc:spChg>
       </pc:sldChg>
       <pc:sldChg chg="addSp delSp modSp mod">
-        <pc:chgData name="Margo Bonal" userId="18c9fa0f-b53d-478b-9dc0-6ad88786c19f" providerId="ADAL" clId="{93D479E5-F67F-4B8A-A78F-A0B574A116B6}" dt="2026-04-16T20:34:54.221" v="1762" actId="20577"/>
+        <pc:chgData name="Margo Bonal" userId="18c9fa0f-b53d-478b-9dc0-6ad88786c19f" providerId="ADAL" clId="{93D479E5-F67F-4B8A-A78F-A0B574A116B6}" dt="2026-04-19T16:43:41.897" v="1801"/>
         <pc:sldMkLst>
           <pc:docMk/>
           <pc:sldMk cId="3526335932" sldId="266"/>
@@ -244,12 +285,12 @@
             <ac:spMk id="4" creationId="{86ED9EE4-56A8-6AFD-BE9A-A35D2ABC59A0}"/>
           </ac:spMkLst>
         </pc:spChg>
-        <pc:spChg chg="del mod">
-          <ac:chgData name="Margo Bonal" userId="18c9fa0f-b53d-478b-9dc0-6ad88786c19f" providerId="ADAL" clId="{93D479E5-F67F-4B8A-A78F-A0B574A116B6}" dt="2026-04-16T20:33:52.540" v="1645" actId="478"/>
+        <pc:spChg chg="add">
+          <ac:chgData name="Margo Bonal" userId="18c9fa0f-b53d-478b-9dc0-6ad88786c19f" providerId="ADAL" clId="{93D479E5-F67F-4B8A-A78F-A0B574A116B6}" dt="2026-04-19T16:43:34.331" v="1799"/>
           <ac:spMkLst>
             <pc:docMk/>
             <pc:sldMk cId="3526335932" sldId="266"/>
-            <ac:spMk id="6" creationId="{3B13CF04-9C06-053E-69E2-58CD31C3D276}"/>
+            <ac:spMk id="6" creationId="{AD648F99-27D0-941D-3C1B-ED58B6E33280}"/>
           </ac:spMkLst>
         </pc:spChg>
         <pc:spChg chg="add mod">
@@ -260,6 +301,93 @@
             <ac:spMk id="7" creationId="{23A9500D-5A04-3835-D25E-8A73CF136F8C}"/>
           </ac:spMkLst>
         </pc:spChg>
+        <pc:spChg chg="add">
+          <ac:chgData name="Margo Bonal" userId="18c9fa0f-b53d-478b-9dc0-6ad88786c19f" providerId="ADAL" clId="{93D479E5-F67F-4B8A-A78F-A0B574A116B6}" dt="2026-04-19T16:43:38.573" v="1800"/>
+          <ac:spMkLst>
+            <pc:docMk/>
+            <pc:sldMk cId="3526335932" sldId="266"/>
+            <ac:spMk id="9" creationId="{3F1528D0-FC78-D30B-7AFC-D7D686E9417D}"/>
+          </ac:spMkLst>
+        </pc:spChg>
+        <pc:picChg chg="add">
+          <ac:chgData name="Margo Bonal" userId="18c9fa0f-b53d-478b-9dc0-6ad88786c19f" providerId="ADAL" clId="{93D479E5-F67F-4B8A-A78F-A0B574A116B6}" dt="2026-04-19T16:43:41.897" v="1801"/>
+          <ac:picMkLst>
+            <pc:docMk/>
+            <pc:sldMk cId="3526335932" sldId="266"/>
+            <ac:picMk id="10" creationId="{F8127E8A-66B9-70E3-BA82-C443670F37B8}"/>
+          </ac:picMkLst>
+        </pc:picChg>
+      </pc:sldChg>
+      <pc:sldChg chg="addSp delSp modSp new mod setBg">
+        <pc:chgData name="Margo Bonal" userId="18c9fa0f-b53d-478b-9dc0-6ad88786c19f" providerId="ADAL" clId="{93D479E5-F67F-4B8A-A78F-A0B574A116B6}" dt="2026-04-19T16:44:14.865" v="1813" actId="14100"/>
+        <pc:sldMkLst>
+          <pc:docMk/>
+          <pc:sldMk cId="3689565289" sldId="267"/>
+        </pc:sldMkLst>
+        <pc:spChg chg="del">
+          <ac:chgData name="Margo Bonal" userId="18c9fa0f-b53d-478b-9dc0-6ad88786c19f" providerId="ADAL" clId="{93D479E5-F67F-4B8A-A78F-A0B574A116B6}" dt="2026-04-19T16:43:48.562" v="1803" actId="478"/>
+          <ac:spMkLst>
+            <pc:docMk/>
+            <pc:sldMk cId="3689565289" sldId="267"/>
+            <ac:spMk id="2" creationId="{E23360D1-A062-B2FC-EEAA-E5E535804AF1}"/>
+          </ac:spMkLst>
+        </pc:spChg>
+        <pc:spChg chg="del">
+          <ac:chgData name="Margo Bonal" userId="18c9fa0f-b53d-478b-9dc0-6ad88786c19f" providerId="ADAL" clId="{93D479E5-F67F-4B8A-A78F-A0B574A116B6}" dt="2026-04-19T16:43:51.542" v="1804" actId="478"/>
+          <ac:spMkLst>
+            <pc:docMk/>
+            <pc:sldMk cId="3689565289" sldId="267"/>
+            <ac:spMk id="3" creationId="{510F054A-47CA-4B84-B793-4D6D16E7A686}"/>
+          </ac:spMkLst>
+        </pc:spChg>
+        <pc:spChg chg="add">
+          <ac:chgData name="Margo Bonal" userId="18c9fa0f-b53d-478b-9dc0-6ad88786c19f" providerId="ADAL" clId="{93D479E5-F67F-4B8A-A78F-A0B574A116B6}" dt="2026-04-19T16:43:52.185" v="1805"/>
+          <ac:spMkLst>
+            <pc:docMk/>
+            <pc:sldMk cId="3689565289" sldId="267"/>
+            <ac:spMk id="4" creationId="{3DEE947E-A037-4125-F15A-949CF0CCE2B6}"/>
+          </ac:spMkLst>
+        </pc:spChg>
+        <pc:spChg chg="add del">
+          <ac:chgData name="Margo Bonal" userId="18c9fa0f-b53d-478b-9dc0-6ad88786c19f" providerId="ADAL" clId="{93D479E5-F67F-4B8A-A78F-A0B574A116B6}" dt="2026-04-19T16:44:01.876" v="1808" actId="26606"/>
+          <ac:spMkLst>
+            <pc:docMk/>
+            <pc:sldMk cId="3689565289" sldId="267"/>
+            <ac:spMk id="10" creationId="{3A930249-8242-4E2B-AF17-C01826488321}"/>
+          </ac:spMkLst>
+        </pc:spChg>
+        <pc:spChg chg="add del">
+          <ac:chgData name="Margo Bonal" userId="18c9fa0f-b53d-478b-9dc0-6ad88786c19f" providerId="ADAL" clId="{93D479E5-F67F-4B8A-A78F-A0B574A116B6}" dt="2026-04-19T16:44:01.876" v="1808" actId="26606"/>
+          <ac:spMkLst>
+            <pc:docMk/>
+            <pc:sldMk cId="3689565289" sldId="267"/>
+            <ac:spMk id="12" creationId="{A5BDD999-C5E1-4B3E-A710-768673819165}"/>
+          </ac:spMkLst>
+        </pc:spChg>
+        <pc:spChg chg="add del">
+          <ac:chgData name="Margo Bonal" userId="18c9fa0f-b53d-478b-9dc0-6ad88786c19f" providerId="ADAL" clId="{93D479E5-F67F-4B8A-A78F-A0B574A116B6}" dt="2026-04-19T16:44:10.449" v="1812" actId="26606"/>
+          <ac:spMkLst>
+            <pc:docMk/>
+            <pc:sldMk cId="3689565289" sldId="267"/>
+            <ac:spMk id="14" creationId="{7B1AB9FE-36F5-4FD1-9850-DB5C5AD4828F}"/>
+          </ac:spMkLst>
+        </pc:spChg>
+        <pc:spChg chg="add del">
+          <ac:chgData name="Margo Bonal" userId="18c9fa0f-b53d-478b-9dc0-6ad88786c19f" providerId="ADAL" clId="{93D479E5-F67F-4B8A-A78F-A0B574A116B6}" dt="2026-04-19T16:44:10.449" v="1812" actId="26606"/>
+          <ac:spMkLst>
+            <pc:docMk/>
+            <pc:sldMk cId="3689565289" sldId="267"/>
+            <ac:spMk id="15" creationId="{F489C2E0-4895-4B72-85EA-7EE9FAFFDC7E}"/>
+          </ac:spMkLst>
+        </pc:spChg>
+        <pc:picChg chg="add mod">
+          <ac:chgData name="Margo Bonal" userId="18c9fa0f-b53d-478b-9dc0-6ad88786c19f" providerId="ADAL" clId="{93D479E5-F67F-4B8A-A78F-A0B574A116B6}" dt="2026-04-19T16:44:14.865" v="1813" actId="14100"/>
+          <ac:picMkLst>
+            <pc:docMk/>
+            <pc:sldMk cId="3689565289" sldId="267"/>
+            <ac:picMk id="5" creationId="{655C8360-2059-FEEA-AE80-0C2B88E1A066}"/>
+          </ac:picMkLst>
+        </pc:picChg>
       </pc:sldChg>
     </pc:docChg>
   </pc:docChgLst>
@@ -2983,7 +3111,7 @@
           <a:p>
             <a:fld id="{B1F2A6E6-BB86-4722-837C-048EA2408876}" type="datetimeFigureOut">
               <a:rPr lang="en-US" smtClean="0"/>
-              <a:t>4/16/2026</a:t>
+              <a:t>4/19/2026</a:t>
             </a:fld>
             <a:endParaRPr lang="en-US"/>
           </a:p>
@@ -3397,7 +3525,7 @@
           <a:p>
             <a:fld id="{C882E6FB-EB88-4936-BED9-9E37159958CA}" type="datetimeFigureOut">
               <a:rPr lang="en-US" smtClean="0"/>
-              <a:t>4/16/2026</a:t>
+              <a:t>4/19/2026</a:t>
             </a:fld>
             <a:endParaRPr lang="en-US"/>
           </a:p>
@@ -3595,7 +3723,7 @@
           <a:p>
             <a:fld id="{C882E6FB-EB88-4936-BED9-9E37159958CA}" type="datetimeFigureOut">
               <a:rPr lang="en-US" smtClean="0"/>
-              <a:t>4/16/2026</a:t>
+              <a:t>4/19/2026</a:t>
             </a:fld>
             <a:endParaRPr lang="en-US"/>
           </a:p>
@@ -3803,7 +3931,7 @@
           <a:p>
             <a:fld id="{C882E6FB-EB88-4936-BED9-9E37159958CA}" type="datetimeFigureOut">
               <a:rPr lang="en-US" smtClean="0"/>
-              <a:t>4/16/2026</a:t>
+              <a:t>4/19/2026</a:t>
             </a:fld>
             <a:endParaRPr lang="en-US"/>
           </a:p>
@@ -4001,7 +4129,7 @@
           <a:p>
             <a:fld id="{C882E6FB-EB88-4936-BED9-9E37159958CA}" type="datetimeFigureOut">
               <a:rPr lang="en-US" smtClean="0"/>
-              <a:t>4/16/2026</a:t>
+              <a:t>4/19/2026</a:t>
             </a:fld>
             <a:endParaRPr lang="en-US"/>
           </a:p>
@@ -4276,7 +4404,7 @@
           <a:p>
             <a:fld id="{C882E6FB-EB88-4936-BED9-9E37159958CA}" type="datetimeFigureOut">
               <a:rPr lang="en-US" smtClean="0"/>
-              <a:t>4/16/2026</a:t>
+              <a:t>4/19/2026</a:t>
             </a:fld>
             <a:endParaRPr lang="en-US"/>
           </a:p>
@@ -4541,7 +4669,7 @@
           <a:p>
             <a:fld id="{C882E6FB-EB88-4936-BED9-9E37159958CA}" type="datetimeFigureOut">
               <a:rPr lang="en-US" smtClean="0"/>
-              <a:t>4/16/2026</a:t>
+              <a:t>4/19/2026</a:t>
             </a:fld>
             <a:endParaRPr lang="en-US"/>
           </a:p>
@@ -4953,7 +5081,7 @@
           <a:p>
             <a:fld id="{C882E6FB-EB88-4936-BED9-9E37159958CA}" type="datetimeFigureOut">
               <a:rPr lang="en-US" smtClean="0"/>
-              <a:t>4/16/2026</a:t>
+              <a:t>4/19/2026</a:t>
             </a:fld>
             <a:endParaRPr lang="en-US"/>
           </a:p>
@@ -5094,7 +5222,7 @@
           <a:p>
             <a:fld id="{C882E6FB-EB88-4936-BED9-9E37159958CA}" type="datetimeFigureOut">
               <a:rPr lang="en-US" smtClean="0"/>
-              <a:t>4/16/2026</a:t>
+              <a:t>4/19/2026</a:t>
             </a:fld>
             <a:endParaRPr lang="en-US"/>
           </a:p>
@@ -5207,7 +5335,7 @@
           <a:p>
             <a:fld id="{C882E6FB-EB88-4936-BED9-9E37159958CA}" type="datetimeFigureOut">
               <a:rPr lang="en-US" smtClean="0"/>
-              <a:t>4/16/2026</a:t>
+              <a:t>4/19/2026</a:t>
             </a:fld>
             <a:endParaRPr lang="en-US"/>
           </a:p>
@@ -5518,7 +5646,7 @@
           <a:p>
             <a:fld id="{C882E6FB-EB88-4936-BED9-9E37159958CA}" type="datetimeFigureOut">
               <a:rPr lang="en-US" smtClean="0"/>
-              <a:t>4/16/2026</a:t>
+              <a:t>4/19/2026</a:t>
             </a:fld>
             <a:endParaRPr lang="en-US"/>
           </a:p>
@@ -5806,7 +5934,7 @@
           <a:p>
             <a:fld id="{C882E6FB-EB88-4936-BED9-9E37159958CA}" type="datetimeFigureOut">
               <a:rPr lang="en-US" smtClean="0"/>
-              <a:t>4/16/2026</a:t>
+              <a:t>4/19/2026</a:t>
             </a:fld>
             <a:endParaRPr lang="en-US"/>
           </a:p>
@@ -6047,7 +6175,7 @@
           <a:p>
             <a:fld id="{C882E6FB-EB88-4936-BED9-9E37159958CA}" type="datetimeFigureOut">
               <a:rPr lang="en-US" smtClean="0"/>
-              <a:t>4/16/2026</a:t>
+              <a:t>4/19/2026</a:t>
             </a:fld>
             <a:endParaRPr lang="en-US"/>
           </a:p>
@@ -9239,6 +9367,66 @@
 <file path=ppt/slides/slide5.xml><?xml version="1.0" encoding="utf-8"?>
 <p:sld xmlns:a="http://schemas.openxmlformats.org/drawingml/2006/main" xmlns:r="http://schemas.openxmlformats.org/officeDocument/2006/relationships" xmlns:p="http://schemas.openxmlformats.org/presentationml/2006/main">
   <p:cSld>
+    <p:spTree>
+      <p:nvGrpSpPr>
+        <p:cNvPr id="1" name=""/>
+        <p:cNvGrpSpPr/>
+        <p:nvPr/>
+      </p:nvGrpSpPr>
+      <p:grpSpPr>
+        <a:xfrm>
+          <a:off x="0" y="0"/>
+          <a:ext cx="0" cy="0"/>
+          <a:chOff x="0" y="0"/>
+          <a:chExt cx="0" cy="0"/>
+        </a:xfrm>
+      </p:grpSpPr>
+      <p:pic>
+        <p:nvPicPr>
+          <p:cNvPr id="5" name="Picture 4">
+            <a:extLst>
+              <a:ext uri="{FF2B5EF4-FFF2-40B4-BE49-F238E27FC236}">
+                <a16:creationId xmlns:a16="http://schemas.microsoft.com/office/drawing/2014/main" id="{655C8360-2059-FEEA-AE80-0C2B88E1A066}"/>
+              </a:ext>
+            </a:extLst>
+          </p:cNvPr>
+          <p:cNvPicPr>
+            <a:picLocks noChangeAspect="1"/>
+          </p:cNvPicPr>
+          <p:nvPr/>
+        </p:nvPicPr>
+        <p:blipFill>
+          <a:blip r:embed="rId2"/>
+          <a:stretch>
+            <a:fillRect/>
+          </a:stretch>
+        </p:blipFill>
+        <p:spPr>
+          <a:xfrm>
+            <a:off x="0" y="-42389"/>
+            <a:ext cx="12192000" cy="6664532"/>
+          </a:xfrm>
+          <a:prstGeom prst="rect">
+            <a:avLst/>
+          </a:prstGeom>
+        </p:spPr>
+      </p:pic>
+    </p:spTree>
+    <p:extLst>
+      <p:ext uri="{BB962C8B-B14F-4D97-AF65-F5344CB8AC3E}">
+        <p14:creationId xmlns:p14="http://schemas.microsoft.com/office/powerpoint/2010/main" val="3689565289"/>
+      </p:ext>
+    </p:extLst>
+  </p:cSld>
+  <p:clrMapOvr>
+    <a:masterClrMapping/>
+  </p:clrMapOvr>
+</p:sld>
+</file>
+
+<file path=ppt/slides/slide6.xml><?xml version="1.0" encoding="utf-8"?>
+<p:sld xmlns:a="http://schemas.openxmlformats.org/drawingml/2006/main" xmlns:r="http://schemas.openxmlformats.org/officeDocument/2006/relationships" xmlns:p="http://schemas.openxmlformats.org/presentationml/2006/main">
+  <p:cSld>
     <p:bg>
       <p:bgPr>
         <a:solidFill>
@@ -9622,7 +9810,7 @@
 </p:sld>
 </file>
 
-<file path=ppt/slides/slide6.xml><?xml version="1.0" encoding="utf-8"?>
+<file path=ppt/slides/slide7.xml><?xml version="1.0" encoding="utf-8"?>
 <p:sld xmlns:a="http://schemas.openxmlformats.org/drawingml/2006/main" xmlns:r="http://schemas.openxmlformats.org/officeDocument/2006/relationships" xmlns:p="http://schemas.openxmlformats.org/presentationml/2006/main">
   <p:cSld>
     <p:bg>
@@ -9964,10 +10152,10 @@
       </p:sp>
       <p:pic>
         <p:nvPicPr>
-          <p:cNvPr id="5" name="Picture 4">
+          <p:cNvPr id="6" name="Picture 5">
             <a:extLst>
               <a:ext uri="{FF2B5EF4-FFF2-40B4-BE49-F238E27FC236}">
-                <a16:creationId xmlns:a16="http://schemas.microsoft.com/office/drawing/2014/main" id="{B0894097-9C9B-8B23-3BC5-11C154EBBAD5}"/>
+                <a16:creationId xmlns:a16="http://schemas.microsoft.com/office/drawing/2014/main" id="{39CFE319-1228-241C-E27B-2F090068170E}"/>
               </a:ext>
             </a:extLst>
           </p:cNvPr>
@@ -9984,17 +10172,12 @@
         </p:blipFill>
         <p:spPr>
           <a:xfrm>
-            <a:off x="0" y="1929448"/>
-            <a:ext cx="12192000" cy="4928551"/>
+            <a:off x="-1" y="1949607"/>
+            <a:ext cx="12143555" cy="4908393"/>
           </a:xfrm>
           <a:prstGeom prst="rect">
             <a:avLst/>
           </a:prstGeom>
-          <a:ln>
-            <a:solidFill>
-              <a:schemeClr val="accent1"/>
-            </a:solidFill>
-          </a:ln>
         </p:spPr>
       </p:pic>
     </p:spTree>
@@ -10010,7 +10193,7 @@
 </p:sld>
 </file>
 
-<file path=ppt/slides/slide7.xml><?xml version="1.0" encoding="utf-8"?>
+<file path=ppt/slides/slide8.xml><?xml version="1.0" encoding="utf-8"?>
 <p:sld xmlns:a="http://schemas.openxmlformats.org/drawingml/2006/main" xmlns:r="http://schemas.openxmlformats.org/officeDocument/2006/relationships" xmlns:p="http://schemas.openxmlformats.org/presentationml/2006/main">
   <p:cSld>
     <p:bg>
@@ -10228,75 +10411,6 @@
           </a:p>
         </p:txBody>
       </p:sp>
-      <p:sp>
-        <p:nvSpPr>
-          <p:cNvPr id="2" name="Title 1">
-            <a:extLst>
-              <a:ext uri="{FF2B5EF4-FFF2-40B4-BE49-F238E27FC236}">
-                <a16:creationId xmlns:a16="http://schemas.microsoft.com/office/drawing/2014/main" id="{9C9AD6B9-1CEE-7976-0BB7-22F5E9535735}"/>
-              </a:ext>
-            </a:extLst>
-          </p:cNvPr>
-          <p:cNvSpPr>
-            <a:spLocks noGrp="1"/>
-          </p:cNvSpPr>
-          <p:nvPr>
-            <p:ph type="title"/>
-          </p:nvPr>
-        </p:nvSpPr>
-        <p:spPr>
-          <a:xfrm>
-            <a:off x="1523999" y="1180494"/>
-            <a:ext cx="9144000" cy="2387600"/>
-          </a:xfrm>
-        </p:spPr>
-        <p:txBody>
-          <a:bodyPr vert="horz" lIns="91440" tIns="45720" rIns="91440" bIns="45720" rtlCol="0" anchor="b">
-            <a:normAutofit/>
-          </a:bodyPr>
-          <a:lstStyle/>
-          <a:p>
-            <a:pPr algn="ctr"/>
-            <a:r>
-              <a:rPr lang="en-US" sz="3500" kern="1200" dirty="0">
-                <a:solidFill>
-                  <a:schemeClr val="tx1"/>
-                </a:solidFill>
-                <a:latin typeface="+mj-lt"/>
-                <a:ea typeface="+mj-ea"/>
-                <a:cs typeface="+mj-cs"/>
-              </a:rPr>
-              <a:t>Website: </a:t>
-            </a:r>
-            <a:r>
-              <a:rPr lang="en-US" sz="3500" kern="1200" dirty="0">
-                <a:solidFill>
-                  <a:srgbClr val="0070C0"/>
-                </a:solidFill>
-                <a:latin typeface="+mj-lt"/>
-                <a:ea typeface="+mj-ea"/>
-                <a:cs typeface="+mj-cs"/>
-                <a:hlinkClick r:id="rId2">
-                  <a:extLst>
-                    <a:ext uri="{A12FA001-AC4F-418D-AE19-62706E023703}">
-                      <ahyp:hlinkClr xmlns:ahyp="http://schemas.microsoft.com/office/drawing/2018/hyperlinkcolor" val="tx"/>
-                    </a:ext>
-                  </a:extLst>
-                </a:hlinkClick>
-              </a:rPr>
-              <a:t>https://jjdeuce06.github.io/VulcanActivityTracker/</a:t>
-            </a:r>
-            <a:endParaRPr lang="en-US" sz="3500" kern="1200" dirty="0">
-              <a:solidFill>
-                <a:srgbClr val="0070C0"/>
-              </a:solidFill>
-              <a:latin typeface="+mj-lt"/>
-              <a:ea typeface="+mj-ea"/>
-              <a:cs typeface="+mj-cs"/>
-            </a:endParaRPr>
-          </a:p>
-        </p:txBody>
-      </p:sp>
       <p:cxnSp>
         <p:nvCxnSpPr>
           <p:cNvPr id="13" name="Straight Connector 12">
@@ -10349,6 +10463,121 @@
           </a:fontRef>
         </p:style>
       </p:cxnSp>
+      <p:sp>
+        <p:nvSpPr>
+          <p:cNvPr id="6" name="Title 1">
+            <a:extLst>
+              <a:ext uri="{FF2B5EF4-FFF2-40B4-BE49-F238E27FC236}">
+                <a16:creationId xmlns:a16="http://schemas.microsoft.com/office/drawing/2014/main" id="{41FAB8FA-2602-2A18-903D-B03E3D5EF300}"/>
+              </a:ext>
+            </a:extLst>
+          </p:cNvPr>
+          <p:cNvSpPr txBox="1">
+            <a:spLocks noGrp="1"/>
+          </p:cNvSpPr>
+          <p:nvPr>
+            <p:ph type="title"/>
+          </p:nvPr>
+        </p:nvSpPr>
+        <p:spPr>
+          <a:xfrm>
+            <a:off x="831850" y="1709738"/>
+            <a:ext cx="10515600" cy="2852737"/>
+          </a:xfrm>
+          <a:prstGeom prst="rect">
+            <a:avLst/>
+          </a:prstGeom>
+        </p:spPr>
+        <p:txBody>
+          <a:bodyPr vert="horz" lIns="91440" tIns="45720" rIns="91440" bIns="45720" rtlCol="0" anchor="b">
+            <a:normAutofit fontScale="92500"/>
+          </a:bodyPr>
+          <a:lstStyle>
+            <a:lvl1pPr algn="l" defTabSz="914400" rtl="0" eaLnBrk="1" latinLnBrk="0" hangingPunct="1">
+              <a:lnSpc>
+                <a:spcPct val="90000"/>
+              </a:lnSpc>
+              <a:spcBef>
+                <a:spcPct val="0"/>
+              </a:spcBef>
+              <a:buNone/>
+              <a:defRPr sz="6000" kern="1200">
+                <a:solidFill>
+                  <a:schemeClr val="tx1"/>
+                </a:solidFill>
+                <a:latin typeface="+mj-lt"/>
+                <a:ea typeface="+mj-ea"/>
+                <a:cs typeface="+mj-cs"/>
+              </a:defRPr>
+            </a:lvl1pPr>
+          </a:lstStyle>
+          <a:p>
+            <a:pPr algn="ctr"/>
+            <a:r>
+              <a:rPr lang="en-US" sz="3500" dirty="0"/>
+              <a:t>Documentation: </a:t>
+            </a:r>
+            <a:r>
+              <a:rPr lang="en-US" sz="3500" dirty="0">
+                <a:solidFill>
+                  <a:srgbClr val="0070C0"/>
+                </a:solidFill>
+                <a:hlinkClick r:id="rId2">
+                  <a:extLst>
+                    <a:ext uri="{A12FA001-AC4F-418D-AE19-62706E023703}">
+                      <ahyp:hlinkClr xmlns:ahyp="http://schemas.microsoft.com/office/drawing/2018/hyperlinkcolor" val="tx"/>
+                    </a:ext>
+                  </a:extLst>
+                </a:hlinkClick>
+              </a:rPr>
+              <a:t>https://jjdeuce06.github.io/VulcanActivityTracker/</a:t>
+            </a:r>
+            <a:endParaRPr lang="en-US" sz="3500" dirty="0">
+              <a:solidFill>
+                <a:srgbClr val="0070C0"/>
+              </a:solidFill>
+            </a:endParaRPr>
+          </a:p>
+          <a:p>
+            <a:endParaRPr lang="en-US" sz="3500" dirty="0">
+              <a:solidFill>
+                <a:srgbClr val="0070C0"/>
+              </a:solidFill>
+            </a:endParaRPr>
+          </a:p>
+          <a:p>
+            <a:pPr algn="ctr"/>
+            <a:r>
+              <a:rPr lang="en-US" sz="3500" dirty="0"/>
+              <a:t>Live: </a:t>
+            </a:r>
+            <a:br>
+              <a:rPr lang="en-US" sz="3500" dirty="0"/>
+            </a:br>
+            <a:r>
+              <a:rPr lang="en-US" sz="3500" dirty="0">
+                <a:solidFill>
+                  <a:srgbClr val="0070C0"/>
+                </a:solidFill>
+              </a:rPr>
+              <a:t>https://vulcanactivitytracker.onrender</a:t>
+            </a:r>
+            <a:r>
+              <a:rPr lang="en-US" sz="3500">
+                <a:solidFill>
+                  <a:srgbClr val="0070C0"/>
+                </a:solidFill>
+              </a:rPr>
+              <a:t>.com</a:t>
+            </a:r>
+            <a:endParaRPr lang="en-US" sz="3500" dirty="0">
+              <a:solidFill>
+                <a:srgbClr val="0070C0"/>
+              </a:solidFill>
+            </a:endParaRPr>
+          </a:p>
+        </p:txBody>
+      </p:sp>
     </p:spTree>
     <p:extLst>
       <p:ext uri="{BB962C8B-B14F-4D97-AF65-F5344CB8AC3E}">

</xml_diff>